<commit_message>
fix(sync): synchronize 8 core project items across website, report, pptx, script, and study guide
</commit_message>
<xml_diff>
--- a/docs/ALFA_University_College_Management_Plan_v4 (1).pptx
+++ b/docs/ALFA_University_College_Management_Plan_v4 (1).pptx
@@ -5332,13 +5332,7 @@
               </a:spcAft>
             </a:pPr>
             <a:r>
-              <a:rPr sz="1400" b="1">
-                <a:solidFill>
-                  <a:srgbClr val="8B0000"/>
-                </a:solidFill>
-                <a:latin typeface="Arial"/>
-              </a:rPr>
-              <a:t>Traffic-Light:   Green &gt;=100%    Amber 85–99%    Red &lt;85%</a:t>
+              <a:t>Traffic-Light:   Green &gt;=100%    Amber 90–99%    Red &lt;90%</a:t>
             </a:r>
           </a:p>
         </p:txBody>
@@ -16323,13 +16317,7 @@
               </a:spcAft>
             </a:pPr>
             <a:r>
-              <a:rPr sz="1400" b="1">
-                <a:solidFill>
-                  <a:srgbClr val="FFFFFF"/>
-                </a:solidFill>
-                <a:latin typeface="Arial"/>
-              </a:rPr>
-              <a:t>M3–M12</a:t>
+              <a:t>M4–M12</a:t>
             </a:r>
           </a:p>
         </p:txBody>

</xml_diff>